<commit_message>
fix(sentinel-demo): rename VP title to vice premier ministre
</commit_message>
<xml_diff>
--- a/docs/sentinel-ci-demo-deck-2026-05-25.pptx
+++ b/docs/sentinel-ci-demo-deck-2026-05-25.pptx
@@ -3176,7 +3176,7 @@
                 </a:solidFill>
                 <a:latin typeface="Calibri"/>
               </a:rPr>
-              <a:t>SENTINEL-CI · Démo Vice-Président</a:t>
+              <a:t>SENTINEL-CI · Démo Vice Premier Ministre</a:t>
             </a:r>
           </a:p>
         </p:txBody>
@@ -3473,7 +3473,7 @@
                 </a:solidFill>
                 <a:latin typeface="Calibri"/>
               </a:rPr>
-              <a:t>SENTINEL-CI · Démo VP · 25 mai 2026</a:t>
+              <a:t>SENTINEL-CI · Démo Vice Premier Ministre · 25 mai 2026</a:t>
             </a:r>
           </a:p>
         </p:txBody>
@@ -3664,7 +3664,7 @@
                 </a:solidFill>
                 <a:latin typeface="Calibri"/>
               </a:rPr>
-              <a:t>SENTINEL-CI · Démo VP · 25 mai 2026</a:t>
+              <a:t>SENTINEL-CI · Démo Vice Premier Ministre · 25 mai 2026</a:t>
             </a:r>
           </a:p>
         </p:txBody>
@@ -4035,7 +4035,7 @@
                 </a:solidFill>
                 <a:latin typeface="Calibri"/>
               </a:rPr>
-              <a:t>SENTINEL-CI · Démo VP · 25 mai 2026</a:t>
+              <a:t>SENTINEL-CI · Démo Vice Premier Ministre · 25 mai 2026</a:t>
             </a:r>
           </a:p>
         </p:txBody>
@@ -4594,7 +4594,7 @@
                 </a:solidFill>
                 <a:latin typeface="Calibri"/>
               </a:rPr>
-              <a:t>SENTINEL-CI · Démo VP · 25 mai 2026</a:t>
+              <a:t>SENTINEL-CI · Démo Vice Premier Ministre · 25 mai 2026</a:t>
             </a:r>
           </a:p>
         </p:txBody>
@@ -5037,7 +5037,7 @@
                 </a:solidFill>
                 <a:latin typeface="Calibri"/>
               </a:rPr>
-              <a:t>SENTINEL-CI · Démo VP · 25 mai 2026</a:t>
+              <a:t>SENTINEL-CI · Démo Vice Premier Ministre · 25 mai 2026</a:t>
             </a:r>
           </a:p>
         </p:txBody>
@@ -5615,7 +5615,7 @@
                 </a:solidFill>
                 <a:latin typeface="Calibri"/>
               </a:rPr>
-              <a:t>SENTINEL-CI · Démo VP · 25 mai 2026</a:t>
+              <a:t>SENTINEL-CI · Démo Vice Premier Ministre · 25 mai 2026</a:t>
             </a:r>
           </a:p>
         </p:txBody>
@@ -6067,7 +6067,7 @@
                 </a:solidFill>
                 <a:latin typeface="Calibri"/>
               </a:rPr>
-              <a:t>SENTINEL-CI · Démo VP · 25 mai 2026</a:t>
+              <a:t>SENTINEL-CI · Démo Vice Premier Ministre · 25 mai 2026</a:t>
             </a:r>
           </a:p>
         </p:txBody>
@@ -6572,7 +6572,7 @@
                 </a:solidFill>
                 <a:latin typeface="Calibri"/>
               </a:rPr>
-              <a:t>SENTINEL-CI · Démo VP · 25 mai 2026</a:t>
+              <a:t>SENTINEL-CI · Démo Vice Premier Ministre · 25 mai 2026</a:t>
             </a:r>
           </a:p>
         </p:txBody>
@@ -8548,7 +8548,7 @@
                 </a:solidFill>
                 <a:latin typeface="Calibri"/>
               </a:rPr>
-              <a:t>SENTINEL-CI · Démo VP · 25 mai 2026</a:t>
+              <a:t>SENTINEL-CI · Démo Vice Premier Ministre · 25 mai 2026</a:t>
             </a:r>
           </a:p>
         </p:txBody>
@@ -8735,7 +8735,7 @@
                 </a:solidFill>
                 <a:latin typeface="Calibri"/>
               </a:rPr>
-              <a:t>SENTINEL-CI · Démo VP · 25 mai 2026</a:t>
+              <a:t>SENTINEL-CI · Démo Vice Premier Ministre · 25 mai 2026</a:t>
             </a:r>
           </a:p>
         </p:txBody>
@@ -8835,7 +8835,7 @@
                 </a:solidFill>
                 <a:latin typeface="Calibri"/>
               </a:rPr>
-              <a:t>SENTINEL-CI · Démo Vice-Président</a:t>
+              <a:t>SENTINEL-CI · Démo Vice Premier Ministre</a:t>
             </a:r>
           </a:p>
         </p:txBody>
@@ -8913,7 +8913,7 @@
                 </a:solidFill>
                 <a:latin typeface="Calibri"/>
               </a:rPr>
-              <a:t>SENTINEL-CI · Démo VP · 25 mai 2026</a:t>
+              <a:t>SENTINEL-CI · Démo Vice Premier Ministre · 25 mai 2026</a:t>
             </a:r>
           </a:p>
         </p:txBody>
@@ -9091,7 +9091,7 @@
                 </a:solidFill>
                 <a:latin typeface="Calibri"/>
               </a:rPr>
-              <a:t>SENTINEL-CI · Démo VP · 25 mai 2026</a:t>
+              <a:t>SENTINEL-CI · Démo Vice Premier Ministre · 25 mai 2026</a:t>
             </a:r>
           </a:p>
         </p:txBody>
@@ -9570,7 +9570,7 @@
                 </a:solidFill>
                 <a:latin typeface="Calibri"/>
               </a:rPr>
-              <a:t>SENTINEL-CI · Démo VP · 25 mai 2026</a:t>
+              <a:t>SENTINEL-CI · Démo Vice Premier Ministre · 25 mai 2026</a:t>
             </a:r>
           </a:p>
         </p:txBody>
@@ -9748,7 +9748,7 @@
                 </a:solidFill>
                 <a:latin typeface="Calibri"/>
               </a:rPr>
-              <a:t>SENTINEL-CI · Démo VP · 25 mai 2026</a:t>
+              <a:t>SENTINEL-CI · Démo Vice Premier Ministre · 25 mai 2026</a:t>
             </a:r>
           </a:p>
         </p:txBody>
@@ -9861,7 +9861,7 @@
                 </a:solidFill>
                 <a:latin typeface="Calibri"/>
               </a:rPr>
-              <a:t> · le VP prépare l’arbitrage avant la rencontre du Préfet de Nawa à Soubré (11h00).</a:t>
+              <a:t> · le Vice Premier Ministre prépare l’arbitrage avant la rencontre du Préfet de Nawa à Soubré (11h00).</a:t>
             </a:r>
           </a:p>
         </p:txBody>
@@ -9939,7 +9939,7 @@
                 </a:solidFill>
                 <a:latin typeface="Calibri"/>
               </a:rPr>
-              <a:t>SENTINEL-CI · Démo VP · 25 mai 2026</a:t>
+              <a:t>SENTINEL-CI · Démo Vice Premier Ministre · 25 mai 2026</a:t>
             </a:r>
           </a:p>
         </p:txBody>
@@ -10319,7 +10319,7 @@
                 </a:solidFill>
                 <a:latin typeface="Calibri"/>
               </a:rPr>
-              <a:t>SENTINEL-CI · Démo VP · 25 mai 2026</a:t>
+              <a:t>SENTINEL-CI · Démo Vice Premier Ministre · 25 mai 2026</a:t>
             </a:r>
           </a:p>
         </p:txBody>
@@ -10834,7 +10834,7 @@
                 </a:solidFill>
                 <a:latin typeface="Calibri"/>
               </a:rPr>
-              <a:t>SENTINEL-CI · Démo VP · 25 mai 2026</a:t>
+              <a:t>SENTINEL-CI · Démo Vice Premier Ministre · 25 mai 2026</a:t>
             </a:r>
           </a:p>
         </p:txBody>
@@ -11286,7 +11286,7 @@
                 </a:solidFill>
                 <a:latin typeface="Calibri"/>
               </a:rPr>
-              <a:t>SENTINEL-CI · Démo VP · 25 mai 2026</a:t>
+              <a:t>SENTINEL-CI · Démo Vice Premier Ministre · 25 mai 2026</a:t>
             </a:r>
           </a:p>
         </p:txBody>
@@ -11815,7 +11815,7 @@
                 </a:solidFill>
                 <a:latin typeface="Calibri"/>
               </a:rPr>
-              <a:t>SENTINEL-CI · Démo VP · 25 mai 2026</a:t>
+              <a:t>SENTINEL-CI · Démo Vice Premier Ministre · 25 mai 2026</a:t>
             </a:r>
           </a:p>
         </p:txBody>
@@ -12402,7 +12402,7 @@
                 </a:solidFill>
                 <a:latin typeface="Calibri"/>
               </a:rPr>
-              <a:t>SENTINEL-CI · Démo VP · 25 mai 2026</a:t>
+              <a:t>SENTINEL-CI · Démo Vice Premier Ministre · 25 mai 2026</a:t>
             </a:r>
           </a:p>
         </p:txBody>
@@ -12922,7 +12922,7 @@
                 </a:solidFill>
                 <a:latin typeface="Calibri"/>
               </a:rPr>
-              <a:t>SENTINEL-CI · Démo VP · 25 mai 2026</a:t>
+              <a:t>SENTINEL-CI · Démo Vice Premier Ministre · 25 mai 2026</a:t>
             </a:r>
           </a:p>
         </p:txBody>
@@ -13232,7 +13232,7 @@
                           </a:solidFill>
                           <a:latin typeface="Calibri"/>
                         </a:rPr>
-                        <a:t>Vice-Président de la République</a:t>
+                        <a:t>Vice Premier Ministre de la République</a:t>
                       </a:r>
                     </a:p>
                   </a:txBody>
@@ -13961,7 +13961,7 @@
                 </a:solidFill>
                 <a:latin typeface="Calibri"/>
               </a:rPr>
-              <a:t>SENTINEL-CI · Démo VP · 25 mai 2026</a:t>
+              <a:t>SENTINEL-CI · Démo Vice Premier Ministre · 25 mai 2026</a:t>
             </a:r>
           </a:p>
         </p:txBody>
@@ -14431,7 +14431,7 @@
                 </a:solidFill>
                 <a:latin typeface="Calibri"/>
               </a:rPr>
-              <a:t>SENTINEL-CI · Démo VP · 25 mai 2026</a:t>
+              <a:t>SENTINEL-CI · Démo Vice Premier Ministre · 25 mai 2026</a:t>
             </a:r>
           </a:p>
         </p:txBody>
@@ -14955,7 +14955,7 @@
                 </a:solidFill>
                 <a:latin typeface="Calibri"/>
               </a:rPr>
-              <a:t>SENTINEL-CI · Démo VP · 25 mai 2026</a:t>
+              <a:t>SENTINEL-CI · Démo Vice Premier Ministre · 25 mai 2026</a:t>
             </a:r>
           </a:p>
         </p:txBody>
@@ -15380,7 +15380,7 @@
                 </a:solidFill>
                 <a:latin typeface="Calibri"/>
               </a:rPr>
-              <a:t>SENTINEL-CI · Démo VP · 25 mai 2026</a:t>
+              <a:t>SENTINEL-CI · Démo Vice Premier Ministre · 25 mai 2026</a:t>
             </a:r>
           </a:p>
         </p:txBody>
@@ -18133,7 +18133,7 @@
                 </a:solidFill>
                 <a:latin typeface="Calibri"/>
               </a:rPr>
-              <a:t>SENTINEL-CI · Démo VP · 25 mai 2026</a:t>
+              <a:t>SENTINEL-CI · Démo Vice Premier Ministre · 25 mai 2026</a:t>
             </a:r>
           </a:p>
         </p:txBody>
@@ -18338,7 +18338,7 @@
                 </a:solidFill>
                 <a:latin typeface="Calibri"/>
               </a:rPr>
-              <a:t>SENTINEL-CI · Démo VP · 25 mai 2026</a:t>
+              <a:t>SENTINEL-CI · Démo Vice Premier Ministre · 25 mai 2026</a:t>
             </a:r>
           </a:p>
         </p:txBody>
@@ -18516,7 +18516,7 @@
                 </a:solidFill>
                 <a:latin typeface="Calibri"/>
               </a:rPr>
-              <a:t>SENTINEL-CI · Démo VP · 25 mai 2026</a:t>
+              <a:t>SENTINEL-CI · Démo Vice Premier Ministre · 25 mai 2026</a:t>
             </a:r>
           </a:p>
         </p:txBody>
@@ -19953,7 +19953,7 @@
                 </a:solidFill>
                 <a:latin typeface="Calibri"/>
               </a:rPr>
-              <a:t>SENTINEL-CI · Démo VP · 25 mai 2026</a:t>
+              <a:t>SENTINEL-CI · Démo Vice Premier Ministre · 25 mai 2026</a:t>
             </a:r>
           </a:p>
         </p:txBody>
@@ -20383,7 +20383,7 @@
                 </a:solidFill>
                 <a:latin typeface="Calibri"/>
               </a:rPr>
-              <a:t>SENTINEL-CI · Démo VP · 25 mai 2026</a:t>
+              <a:t>SENTINEL-CI · Démo Vice Premier Ministre · 25 mai 2026</a:t>
             </a:r>
           </a:p>
         </p:txBody>
@@ -21735,7 +21735,7 @@
                 </a:solidFill>
                 <a:latin typeface="Calibri"/>
               </a:rPr>
-              <a:t>SENTINEL-CI · Démo VP · 25 mai 2026</a:t>
+              <a:t>SENTINEL-CI · Démo Vice Premier Ministre · 25 mai 2026</a:t>
             </a:r>
           </a:p>
         </p:txBody>
@@ -21980,7 +21980,7 @@
                 </a:solidFill>
                 <a:latin typeface="Calibri"/>
               </a:rPr>
-              <a:t>SENTINEL-CI · Démo VP · 25 mai 2026</a:t>
+              <a:t>SENTINEL-CI · Démo Vice Premier Ministre · 25 mai 2026</a:t>
             </a:r>
           </a:p>
         </p:txBody>
@@ -22366,7 +22366,7 @@
                 </a:solidFill>
                 <a:latin typeface="Calibri"/>
               </a:rPr>
-              <a:t>SENTINEL-CI · Démo VP · 25 mai 2026</a:t>
+              <a:t>SENTINEL-CI · Démo Vice Premier Ministre · 25 mai 2026</a:t>
             </a:r>
           </a:p>
         </p:txBody>
@@ -22496,7 +22496,7 @@
                 </a:solidFill>
                 <a:latin typeface="Calibri"/>
               </a:rPr>
-              <a:t>Valeurs cohérentes pour la démo (figées dans le seed Osiris CI) — à citer si le VP regarde le bloc INDICATEURS MACRO :</a:t>
+              <a:t>Valeurs cohérentes pour la démo (figées dans le seed Osiris CI) — à citer si le Vice Premier Ministre regarde le bloc INDICATEURS MACRO :</a:t>
             </a:r>
           </a:p>
         </p:txBody>
@@ -23942,7 +23942,7 @@
                 </a:solidFill>
                 <a:latin typeface="Calibri"/>
               </a:rPr>
-              <a:t>SENTINEL-CI · Démo VP · 25 mai 2026</a:t>
+              <a:t>SENTINEL-CI · Démo Vice Premier Ministre · 25 mai 2026</a:t>
             </a:r>
           </a:p>
         </p:txBody>
@@ -24115,7 +24115,7 @@
                 </a:solidFill>
                 <a:latin typeface="Calibri"/>
               </a:rPr>
-              <a:t>SENTINEL-CI · Démo VP · 25 mai 2026</a:t>
+              <a:t>SENTINEL-CI · Démo Vice Premier Ministre · 25 mai 2026</a:t>
             </a:r>
           </a:p>
         </p:txBody>
@@ -24293,7 +24293,7 @@
                 </a:solidFill>
                 <a:latin typeface="Calibri"/>
               </a:rPr>
-              <a:t>SENTINEL-CI · Démo VP · 25 mai 2026</a:t>
+              <a:t>SENTINEL-CI · Démo Vice Premier Ministre · 25 mai 2026</a:t>
             </a:r>
           </a:p>
         </p:txBody>
@@ -27045,7 +27045,7 @@
                 </a:solidFill>
                 <a:latin typeface="Calibri"/>
               </a:rPr>
-              <a:t>SENTINEL-CI · Démo VP · 25 mai 2026</a:t>
+              <a:t>SENTINEL-CI · Démo Vice Premier Ministre · 25 mai 2026</a:t>
             </a:r>
           </a:p>
         </p:txBody>
@@ -29600,7 +29600,7 @@
                 </a:solidFill>
                 <a:latin typeface="Calibri"/>
               </a:rPr>
-              <a:t>SENTINEL-CI · Démo VP · 25 mai 2026</a:t>
+              <a:t>SENTINEL-CI · Démo Vice Premier Ministre · 25 mai 2026</a:t>
             </a:r>
           </a:p>
         </p:txBody>
@@ -32792,7 +32792,7 @@
                 </a:solidFill>
                 <a:latin typeface="Calibri"/>
               </a:rPr>
-              <a:t>SENTINEL-CI · Démo VP · 25 mai 2026</a:t>
+              <a:t>SENTINEL-CI · Démo Vice Premier Ministre · 25 mai 2026</a:t>
             </a:r>
           </a:p>
         </p:txBody>
@@ -34008,7 +34008,7 @@
                 </a:solidFill>
                 <a:latin typeface="Calibri"/>
               </a:rPr>
-              <a:t>SENTINEL-CI · Démo VP · 25 mai 2026</a:t>
+              <a:t>SENTINEL-CI · Démo Vice Premier Ministre · 25 mai 2026</a:t>
             </a:r>
           </a:p>
         </p:txBody>
@@ -34150,7 +34150,7 @@
                 </a:solidFill>
                 <a:latin typeface="Calibri"/>
               </a:rPr>
-              <a:t>« Monsieur le Vice-Président, voici SENTINEL-CI : un cockpit souverain de gouvernance, opéré en mode advisory — AYA propose, le Cabinet décide. »</a:t>
+              <a:t>« Monsieur le Vice Premier Ministre, voici SENTINEL-CI : un cockpit souverain de gouvernance, opéré en mode advisory — AYA propose, le Cabinet décide. »</a:t>
             </a:r>
           </a:p>
           <a:p>
@@ -34333,7 +34333,7 @@
                 </a:solidFill>
                 <a:latin typeface="Calibri"/>
               </a:rPr>
-              <a:t>SENTINEL-CI · Démo VP · 25 mai 2026</a:t>
+              <a:t>SENTINEL-CI · Démo Vice Premier Ministre · 25 mai 2026</a:t>
             </a:r>
           </a:p>
         </p:txBody>
@@ -34570,16 +34570,16 @@
                 </a:solidFill>
                 <a:latin typeface="Calibri"/>
               </a:rPr>
-              <a:t>« Monsieur le Vice-Président »</a:t>
-            </a:r>
-            <a:r>
-              <a:rPr sz="1300">
-                <a:solidFill>
-                  <a:srgbClr val="E2E8F0"/>
-                </a:solidFill>
-                <a:latin typeface="Calibri"/>
-              </a:rPr>
-              <a:t> (jamais « M. le Vice-Président » — TTS prononce « M » comme la lettre).</a:t>
+              <a:t>« Monsieur le Vice Premier Ministre »</a:t>
+            </a:r>
+            <a:r>
+              <a:rPr sz="1300">
+                <a:solidFill>
+                  <a:srgbClr val="E2E8F0"/>
+                </a:solidFill>
+                <a:latin typeface="Calibri"/>
+              </a:rPr>
+              <a:t> (jamais « M. le Vice Premier Ministre » — TTS prononce « M » comme la lettre).</a:t>
             </a:r>
           </a:p>
           <a:p>
@@ -34789,7 +34789,7 @@
                 </a:solidFill>
                 <a:latin typeface="Calibri"/>
               </a:rPr>
-              <a:t>SENTINEL-CI · Démo VP · 25 mai 2026</a:t>
+              <a:t>SENTINEL-CI · Démo Vice Premier Ministre · 25 mai 2026</a:t>
             </a:r>
           </a:p>
         </p:txBody>
@@ -34902,7 +34902,7 @@
                 </a:solidFill>
                 <a:latin typeface="Calibri"/>
               </a:rPr>
-              <a:t> démo VP</a:t>
+              <a:t> démo Vice Premier Ministre</a:t>
             </a:r>
           </a:p>
         </p:txBody>
@@ -35078,7 +35078,7 @@
                 </a:solidFill>
                 <a:latin typeface="Calibri"/>
               </a:rPr>
-              <a:t>SENTINEL-CI · Démo VP · 25 mai 2026</a:t>
+              <a:t>SENTINEL-CI · Démo Vice Premier Ministre · 25 mai 2026</a:t>
             </a:r>
           </a:p>
         </p:txBody>
@@ -35256,7 +35256,7 @@
                 </a:solidFill>
                 <a:latin typeface="Calibri"/>
               </a:rPr>
-              <a:t>SENTINEL-CI · Démo VP · 25 mai 2026</a:t>
+              <a:t>SENTINEL-CI · Démo Vice Premier Ministre · 25 mai 2026</a:t>
             </a:r>
           </a:p>
         </p:txBody>
@@ -35740,7 +35740,7 @@
                 </a:solidFill>
                 <a:latin typeface="Calibri"/>
               </a:rPr>
-              <a:t>SENTINEL-CI · Démo VP · 25 mai 2026</a:t>
+              <a:t>SENTINEL-CI · Démo Vice Premier Ministre · 25 mai 2026</a:t>
             </a:r>
           </a:p>
         </p:txBody>
@@ -37325,7 +37325,7 @@
                 </a:solidFill>
                 <a:latin typeface="Calibri"/>
               </a:rPr>
-              <a:t>SENTINEL-CI · Démo VP · 25 mai 2026</a:t>
+              <a:t>SENTINEL-CI · Démo Vice Premier Ministre · 25 mai 2026</a:t>
             </a:r>
           </a:p>
         </p:txBody>
@@ -37592,7 +37592,7 @@
                 </a:solidFill>
                 <a:latin typeface="Calibri"/>
               </a:rPr>
-              <a:t>SENTINEL-CI · Démo VP · 25 mai 2026</a:t>
+              <a:t>SENTINEL-CI · Démo Vice Premier Ministre · 25 mai 2026</a:t>
             </a:r>
           </a:p>
         </p:txBody>
@@ -38081,7 +38081,7 @@
                 </a:solidFill>
                 <a:latin typeface="Calibri"/>
               </a:rPr>
-              <a:t>SENTINEL-CI · Démo VP · 25 mai 2026</a:t>
+              <a:t>SENTINEL-CI · Démo Vice Premier Ministre · 25 mai 2026</a:t>
             </a:r>
           </a:p>
         </p:txBody>

</xml_diff>